<commit_message>
Remove equity references from shared materials
</commit_message>
<xml_diff>
--- a/tercier-deck-march-2026.pptx
+++ b/tercier-deck-march-2026.pptx
@@ -4130,7 +4130,7 @@
                 <a:ea typeface="Calibri" pitchFamily="34" charset="-122"/>
                 <a:cs typeface="Calibri" pitchFamily="34" charset="-120"/>
               </a:rPr>
-              <a:t>Salary: CHF 4K/mo (wife earns CHF 130K, this works)</a:t>
+              <a:t>Salary: CHF 4K/mo to start</a:t>
             </a:r>
             <a:endParaRPr lang="en-US" sz="1200" dirty="0"/>
           </a:p>
@@ -4166,7 +4166,7 @@
                 <a:ea typeface="Calibri" pitchFamily="34" charset="-122"/>
                 <a:cs typeface="Calibri" pitchFamily="34" charset="-120"/>
               </a:rPr>
-              <a:t>2% MRR revenue share</a:t>
+              <a:t>Full-time operator commitment from day one</a:t>
             </a:r>
             <a:endParaRPr lang="en-US" sz="1200" dirty="0"/>
           </a:p>
@@ -4184,7 +4184,7 @@
                 <a:ea typeface="Calibri" pitchFamily="34" charset="-122"/>
                 <a:cs typeface="Calibri" pitchFamily="34" charset="-120"/>
               </a:rPr>
-              <a:t>Equity: contribution-based, targeting 38%</a:t>
+              <a:t>Lean company setup: burn stays disciplined until revenue scales</a:t>
             </a:r>
             <a:endParaRPr lang="en-US" sz="1200" dirty="0"/>
           </a:p>

</xml_diff>